<commit_message>
view Akust_Fenster_u_vorbeiflug erfolgreich geschaffen
</commit_message>
<xml_diff>
--- a/dataflow.pptx
+++ b/dataflow.pptx
@@ -3438,6 +3438,14 @@
             </a:r>
             <a:r>
               <a:rPr lang="de-DE" sz="1100" dirty="0"/>
+              <a:t>, </a:t>
+            </a:r>
+            <a:r>
+              <a:rPr lang="de-DE" sz="1100" dirty="0" err="1"/>
+              <a:t>perzentilenpegel</a:t>
+            </a:r>
+            <a:r>
+              <a:rPr lang="de-DE" sz="1100" dirty="0"/>
               <a:t>)</a:t>
             </a:r>
           </a:p>
@@ -3750,14 +3758,14 @@
           <p:cNvCxnSpPr>
             <a:cxnSpLocks/>
             <a:stCxn id="14" idx="4"/>
-            <a:endCxn id="30" idx="0"/>
+            <a:endCxn id="22" idx="0"/>
           </p:cNvCxnSpPr>
           <p:nvPr/>
         </p:nvCxnSpPr>
         <p:spPr>
           <a:xfrm>
             <a:off x="1548063" y="4116962"/>
-            <a:ext cx="0" cy="589858"/>
+            <a:ext cx="0" cy="495088"/>
           </a:xfrm>
           <a:prstGeom prst="straightConnector1">
             <a:avLst/>
@@ -3795,7 +3803,7 @@
         </p:nvSpPr>
         <p:spPr>
           <a:xfrm>
-            <a:off x="164431" y="4706820"/>
+            <a:off x="164431" y="5845803"/>
             <a:ext cx="2767264" cy="747495"/>
           </a:xfrm>
           <a:prstGeom prst="ellipse">
@@ -3863,7 +3871,7 @@
             </a:r>
             <a:r>
               <a:rPr lang="de-DE" sz="1100" dirty="0" err="1"/>
-              <a:t>ereignis_ID,perzentilenpegel</a:t>
+              <a:t>ereignis_ID</a:t>
             </a:r>
             <a:r>
               <a:rPr lang="de-DE" sz="1100" dirty="0"/>
@@ -3929,7 +3937,7 @@
         </p:nvSpPr>
         <p:spPr>
           <a:xfrm>
-            <a:off x="5971672" y="4718806"/>
+            <a:off x="5971672" y="5857789"/>
             <a:ext cx="2767264" cy="747495"/>
           </a:xfrm>
           <a:prstGeom prst="ellipse">
@@ -4009,7 +4017,7 @@
         </p:nvSpPr>
         <p:spPr>
           <a:xfrm>
-            <a:off x="3761873" y="4830944"/>
+            <a:off x="3761873" y="5969927"/>
             <a:ext cx="1379620" cy="523220"/>
           </a:xfrm>
           <a:prstGeom prst="rect">
@@ -4062,7 +4070,7 @@
         </p:nvCxnSpPr>
         <p:spPr>
           <a:xfrm>
-            <a:off x="2931695" y="5080568"/>
+            <a:off x="2931695" y="6219551"/>
             <a:ext cx="830178" cy="11986"/>
           </a:xfrm>
           <a:prstGeom prst="straightConnector1">
@@ -4105,7 +4113,7 @@
         </p:nvCxnSpPr>
         <p:spPr>
           <a:xfrm>
-            <a:off x="5141493" y="5092554"/>
+            <a:off x="5141493" y="6231537"/>
             <a:ext cx="830179" cy="0"/>
           </a:xfrm>
           <a:prstGeom prst="straightConnector1">
@@ -4276,13 +4284,14 @@
           </p:cNvPr>
           <p:cNvCxnSpPr>
             <a:cxnSpLocks/>
+            <a:stCxn id="34" idx="0"/>
           </p:cNvCxnSpPr>
           <p:nvPr/>
         </p:nvCxnSpPr>
         <p:spPr>
           <a:xfrm flipV="1">
-            <a:off x="7355304" y="4116962"/>
-            <a:ext cx="0" cy="601844"/>
+            <a:off x="7355304" y="4116963"/>
+            <a:ext cx="0" cy="1740826"/>
           </a:xfrm>
           <a:prstGeom prst="straightConnector1">
             <a:avLst/>
@@ -4397,6 +4406,98 @@
           </a:p>
         </p:txBody>
       </p:sp>
+      <p:sp>
+        <p:nvSpPr>
+          <p:cNvPr id="22" name="Textfeld 21">
+            <a:extLst>
+              <a:ext uri="{FF2B5EF4-FFF2-40B4-BE49-F238E27FC236}">
+                <a16:creationId xmlns:a16="http://schemas.microsoft.com/office/drawing/2014/main" id="{A4E01DCB-4667-42A3-90CD-EEA0CFEB68AC}"/>
+              </a:ext>
+            </a:extLst>
+          </p:cNvPr>
+          <p:cNvSpPr txBox="1"/>
+          <p:nvPr/>
+        </p:nvSpPr>
+        <p:spPr>
+          <a:xfrm>
+            <a:off x="990600" y="4612050"/>
+            <a:ext cx="1114926" cy="738664"/>
+          </a:xfrm>
+          <a:prstGeom prst="rect">
+            <a:avLst/>
+          </a:prstGeom>
+        </p:spPr>
+        <p:style>
+          <a:lnRef idx="2">
+            <a:schemeClr val="accent2"/>
+          </a:lnRef>
+          <a:fillRef idx="1">
+            <a:schemeClr val="lt1"/>
+          </a:fillRef>
+          <a:effectRef idx="0">
+            <a:schemeClr val="accent2"/>
+          </a:effectRef>
+          <a:fontRef idx="minor">
+            <a:schemeClr val="dk1"/>
+          </a:fontRef>
+        </p:style>
+        <p:txBody>
+          <a:bodyPr wrap="square" rtlCol="0">
+            <a:spAutoFit/>
+          </a:bodyPr>
+          <a:lstStyle/>
+          <a:p>
+            <a:r>
+              <a:rPr lang="de-DE" sz="1400" dirty="0" err="1"/>
+              <a:t>Pegelschrieb_m_Fenster_Flug</a:t>
+            </a:r>
+            <a:endParaRPr lang="de-DE" sz="1400" dirty="0"/>
+          </a:p>
+        </p:txBody>
+      </p:sp>
+      <p:cxnSp>
+        <p:nvCxnSpPr>
+          <p:cNvPr id="25" name="Gerade Verbindung mit Pfeil 24">
+            <a:extLst>
+              <a:ext uri="{FF2B5EF4-FFF2-40B4-BE49-F238E27FC236}">
+                <a16:creationId xmlns:a16="http://schemas.microsoft.com/office/drawing/2014/main" id="{4C9E104B-B64C-49A2-9356-A6F27B110FBF}"/>
+              </a:ext>
+            </a:extLst>
+          </p:cNvPr>
+          <p:cNvCxnSpPr>
+            <a:cxnSpLocks/>
+            <a:stCxn id="22" idx="2"/>
+            <a:endCxn id="30" idx="0"/>
+          </p:cNvCxnSpPr>
+          <p:nvPr/>
+        </p:nvCxnSpPr>
+        <p:spPr>
+          <a:xfrm>
+            <a:off x="1548063" y="5350714"/>
+            <a:ext cx="0" cy="495089"/>
+          </a:xfrm>
+          <a:prstGeom prst="straightConnector1">
+            <a:avLst/>
+          </a:prstGeom>
+          <a:ln>
+            <a:tailEnd type="triangle"/>
+          </a:ln>
+        </p:spPr>
+        <p:style>
+          <a:lnRef idx="1">
+            <a:schemeClr val="accent1"/>
+          </a:lnRef>
+          <a:fillRef idx="0">
+            <a:schemeClr val="accent1"/>
+          </a:fillRef>
+          <a:effectRef idx="0">
+            <a:schemeClr val="accent1"/>
+          </a:effectRef>
+          <a:fontRef idx="minor">
+            <a:schemeClr val="tx1"/>
+          </a:fontRef>
+        </p:style>
+      </p:cxnSp>
     </p:spTree>
     <p:extLst>
       <p:ext uri="{BB962C8B-B14F-4D97-AF65-F5344CB8AC3E}">

</xml_diff>